<commit_message>
Alphabet Q3 2026: margin-led core message and call-transcript insights
Rebuild the update around the margin squeeze (EPS miss mostly the SpaceX
mark-to-market), with a CFO depreciation quote, Search slowdown drivers,
the EC fine in free cash flow, shared AI costs outside the Cloud margin,
AI Mode ads and the unchanged capex range from the call.

Co-Authored-By: Claude Opus 5.5 <noreply@anthropic.com>
Claude-Session: https://claude.ai/code/session_0194roGPqBhaRAXzfYFupgCj
</commit_message>
<xml_diff>
--- a/deliverables/GOOGL_Q3_2026/Earnings_Update_GOOGL_Q32026.pptx
+++ b/deliverables/GOOGL_Q3_2026/Earnings_Update_GOOGL_Q32026.pptx
@@ -1254,7 +1254,7 @@
                 <a:ea typeface="Nunito" pitchFamily="34" charset="-122"/>
                 <a:cs typeface="Nunito" pitchFamily="34" charset="-120"/>
               </a:rPr>
-              <a:t>Alphabet Q3 2026: Cloud doubles, capex drains cash flow</a:t>
+              <a:t>Alphabet Q3 2026: good for AI growth, tough on margins</a:t>
             </a:r>
             <a:endParaRPr lang="en-US" sz="1700" dirty="0"/>
           </a:p>
@@ -1360,7 +1360,7 @@
                 <a:ea typeface="Nunito" pitchFamily="34" charset="-122"/>
                 <a:cs typeface="Nunito" pitchFamily="34" charset="-120"/>
               </a:rPr>
-              <a:t>“Google Cloud revenues grew 103%, powered by huge demand for our AI infrastructure and AI solutions. We’re also seeing strong demand for our TPU systems across a wide range of customers.”</a:t>
+              <a:t>“The significant increase in our investment in technical infrastructure will continue to weigh on the P&amp;L in the form of higher depreciation expenses and related data center operations costs, such as energy.”</a:t>
             </a:r>
             <a:endParaRPr lang="en-US" sz="870" dirty="0"/>
           </a:p>
@@ -1399,7 +1399,7 @@
                 <a:ea typeface="Nunito" pitchFamily="34" charset="-122"/>
                 <a:cs typeface="Nunito" pitchFamily="34" charset="-120"/>
               </a:rPr>
-              <a:t>Sundar Pichai, CEO, Alphabet Q3 2026 results, 28 October 2026</a:t>
+              <a:t>Anat Ashkenazi, CFO, Alphabet Q3 2026 earnings call, 28 October 2026</a:t>
             </a:r>
             <a:endParaRPr lang="en-US" sz="700" dirty="0"/>
           </a:p>
@@ -1561,7 +1561,7 @@
                 <a:ea typeface="Nunito" pitchFamily="34" charset="-122"/>
                 <a:cs typeface="Nunito" pitchFamily="34" charset="-120"/>
               </a:rPr>
-              <a:t>EPS of USD 2.12 missed consensus by 30%; a USD 8.7bn equity-stake loss explains 60% of the gap.</a:t>
+              <a:t>EPS of USD 2.12 missed consensus by 30%, mostly on a USD 0.55 loss on the SpaceX stake.</a:t>
             </a:r>
             <a:endParaRPr lang="en-US" sz="870" dirty="0"/>
           </a:p>
@@ -1594,13 +1594,13 @@
             <a:r>
               <a:rPr lang="en-US" sz="700" b="1" spc="80" kern="0" dirty="0">
                 <a:solidFill>
-                  <a:srgbClr val="3BAF90"/>
-                </a:solidFill>
-                <a:latin typeface="Nunito" pitchFamily="34" charset="0"/>
-                <a:ea typeface="Nunito" pitchFamily="34" charset="-122"/>
-                <a:cs typeface="Nunito" pitchFamily="34" charset="-120"/>
-              </a:rPr>
-              <a:t>Beat</a:t>
+                  <a:srgbClr val="FF6C0E"/>
+                </a:solidFill>
+                <a:latin typeface="Nunito" pitchFamily="34" charset="0"/>
+                <a:ea typeface="Nunito" pitchFamily="34" charset="-122"/>
+                <a:cs typeface="Nunito" pitchFamily="34" charset="-120"/>
+              </a:rPr>
+              <a:t>Margin</a:t>
             </a:r>
             <a:endParaRPr lang="en-US" sz="700" dirty="0"/>
           </a:p>
@@ -1642,7 +1642,7 @@
                 <a:ea typeface="Nunito" pitchFamily="34" charset="-122"/>
                 <a:cs typeface="Nunito" pitchFamily="34" charset="-120"/>
               </a:rPr>
-              <a:t>Google Cloud revenue doubled to USD 30.7bn, 5% above consensus, and its operating margin reached 36%.</a:t>
+              <a:t>Operating margin fell to 31.8% from 34.0% as depreciation rose; operating profit missed by about 6%.</a:t>
             </a:r>
             <a:endParaRPr lang="en-US" sz="870" dirty="0"/>
           </a:p>
@@ -1675,13 +1675,13 @@
             <a:r>
               <a:rPr lang="en-US" sz="700" b="1" spc="80" kern="0" dirty="0">
                 <a:solidFill>
-                  <a:srgbClr val="FF6C0E"/>
-                </a:solidFill>
-                <a:latin typeface="Nunito" pitchFamily="34" charset="0"/>
-                <a:ea typeface="Nunito" pitchFamily="34" charset="-122"/>
-                <a:cs typeface="Nunito" pitchFamily="34" charset="-120"/>
-              </a:rPr>
-              <a:t>Reaction</a:t>
+                  <a:srgbClr val="3BAF90"/>
+                </a:solidFill>
+                <a:latin typeface="Nunito" pitchFamily="34" charset="0"/>
+                <a:ea typeface="Nunito" pitchFamily="34" charset="-122"/>
+                <a:cs typeface="Nunito" pitchFamily="34" charset="-120"/>
+              </a:rPr>
+              <a:t>Growth</a:t>
             </a:r>
             <a:endParaRPr lang="en-US" sz="700" dirty="0"/>
           </a:p>
@@ -1723,7 +1723,7 @@
                 <a:ea typeface="Nunito" pitchFamily="34" charset="-122"/>
                 <a:cs typeface="Nunito" pitchFamily="34" charset="-120"/>
               </a:rPr>
-              <a:t>Shares are down over 10% pre-market on 29 October: margins fell and free cash flow turned negative.</a:t>
+              <a:t>Revenue grew 25% and Google Cloud doubled to USD 30.7bn, with USD 561bn of contracts booked.</a:t>
             </a:r>
             <a:endParaRPr lang="en-US" sz="870" dirty="0"/>
           </a:p>
@@ -1756,13 +1756,13 @@
             <a:r>
               <a:rPr lang="en-US" sz="700" b="1" spc="80" kern="0" dirty="0">
                 <a:solidFill>
-                  <a:srgbClr val="4B5F80"/>
-                </a:solidFill>
-                <a:latin typeface="Nunito" pitchFamily="34" charset="0"/>
-                <a:ea typeface="Nunito" pitchFamily="34" charset="-122"/>
-                <a:cs typeface="Nunito" pitchFamily="34" charset="-120"/>
-              </a:rPr>
-              <a:t>Valuation</a:t>
+                  <a:srgbClr val="FF6C0E"/>
+                </a:solidFill>
+                <a:latin typeface="Nunito" pitchFamily="34" charset="0"/>
+                <a:ea typeface="Nunito" pitchFamily="34" charset="-122"/>
+                <a:cs typeface="Nunito" pitchFamily="34" charset="-120"/>
+              </a:rPr>
+              <a:t>Reaction</a:t>
             </a:r>
             <a:endParaRPr lang="en-US" sz="700" dirty="0"/>
           </a:p>
@@ -1804,7 +1804,7 @@
                 <a:ea typeface="Nunito" pitchFamily="34" charset="-122"/>
                 <a:cs typeface="Nunito" pitchFamily="34" charset="-120"/>
               </a:rPr>
-              <a:t>Near USD 292, the stock trades on 17.7x forward earnings, 10% below its 2010 to 2026 average.</a:t>
+              <a:t>Shares are down over 10% pre-market on 29 October, to about 17.7x forward earnings, below average.</a:t>
             </a:r>
             <a:endParaRPr lang="en-US" sz="870" dirty="0"/>
           </a:p>
@@ -1870,7 +1870,7 @@
                 <a:ea typeface="Nunito" pitchFamily="34" charset="-122"/>
                 <a:cs typeface="Nunito" pitchFamily="34" charset="-120"/>
               </a:rPr>
-              <a:t>Revenue</a:t>
+              <a:t>EPS</a:t>
             </a:r>
             <a:endParaRPr lang="en-US" sz="700" dirty="0"/>
           </a:p>
@@ -1909,7 +1909,7 @@
                 <a:ea typeface="Nunito" pitchFamily="34" charset="-122"/>
                 <a:cs typeface="Nunito" pitchFamily="34" charset="-120"/>
               </a:rPr>
-              <a:t>USD 127.6bn</a:t>
+              <a:t>USD 2.12</a:t>
             </a:r>
             <a:endParaRPr lang="en-US" sz="1100" dirty="0"/>
           </a:p>
@@ -1948,7 +1948,7 @@
                 <a:ea typeface="Nunito" pitchFamily="34" charset="-122"/>
                 <a:cs typeface="Nunito" pitchFamily="34" charset="-120"/>
               </a:rPr>
-              <a:t>-0.5% vs. consensus</a:t>
+              <a:t>-29.6% vs. consensus</a:t>
             </a:r>
             <a:endParaRPr lang="en-US" sz="700" dirty="0"/>
           </a:p>
@@ -2010,7 +2010,7 @@
                 <a:ea typeface="Nunito" pitchFamily="34" charset="-122"/>
                 <a:cs typeface="Nunito" pitchFamily="34" charset="-120"/>
               </a:rPr>
-              <a:t>EPS</a:t>
+              <a:t>Operating margin</a:t>
             </a:r>
             <a:endParaRPr lang="en-US" sz="700" dirty="0"/>
           </a:p>
@@ -2049,7 +2049,7 @@
                 <a:ea typeface="Nunito" pitchFamily="34" charset="-122"/>
                 <a:cs typeface="Nunito" pitchFamily="34" charset="-120"/>
               </a:rPr>
-              <a:t>USD 2.12</a:t>
+              <a:t>31.8%</a:t>
             </a:r>
             <a:endParaRPr lang="en-US" sz="1100" dirty="0"/>
           </a:p>
@@ -2088,7 +2088,7 @@
                 <a:ea typeface="Nunito" pitchFamily="34" charset="-122"/>
                 <a:cs typeface="Nunito" pitchFamily="34" charset="-120"/>
               </a:rPr>
-              <a:t>-29.6% vs. consensus</a:t>
+              <a:t>34.0% in Q2 2026</a:t>
             </a:r>
             <a:endParaRPr lang="en-US" sz="700" dirty="0"/>
           </a:p>
@@ -2407,7 +2407,7 @@
                 <a:ea typeface="Nunito" pitchFamily="34" charset="-122"/>
                 <a:cs typeface="Nunito" pitchFamily="34" charset="-120"/>
               </a:rPr>
-              <a:t>The debate moves to the return on capex</a:t>
+              <a:t>Margins explain the fall better than EPS</a:t>
             </a:r>
             <a:endParaRPr lang="en-US" sz="1100" dirty="0"/>
           </a:p>
@@ -2449,7 +2449,7 @@
                 <a:ea typeface="Nunito" pitchFamily="34" charset="-122"/>
                 <a:cs typeface="Nunito" pitchFamily="34" charset="-120"/>
               </a:rPr>
-              <a:t>Revenue missed consensus by 0.5% and EPS by 30%, and the shares are down over 10% pre-market on 29 October, below USD 300. The fall is larger than the operating miss of about 6%. We read it as a verdict on the investment cycle: free cash flow was -USD 9.1bn, share buybacks stopped and capital expenditure (capex) of USD 51.4bn absorbed 40% of revenue.</a:t>
+              <a:t>EPS missed consensus by 30% and the shares are down over 10% pre-market on 29 October, below USD 300. The EPS miss says little about Search, YouTube or Cloud: most of it is a loss on the SpaceX stake. The margin matters more. It fell to 31.8% from 34.0% in Q2 as depreciation on the AI build-out rose, and operating profit missed by about 6%.</a:t>
             </a:r>
             <a:endParaRPr lang="en-US" sz="870" dirty="0"/>
           </a:p>
@@ -2610,7 +2610,7 @@
                 <a:ea typeface="Nunito" pitchFamily="34" charset="-122"/>
                 <a:cs typeface="Nunito" pitchFamily="34" charset="-120"/>
               </a:rPr>
-              <a:t>The quarter splits in two. Google Cloud beat consensus by 5% on revenue and by 14% on operating income. Advertising fell short, with Search 2.5% and YouTube ads 1.7% below estimates. Excluding the USD 0.55 equity loss, EPS of USD 2.67 sits 11% under consensus, and operating cash flow came in 20% short.</a:t>
+              <a:t>Google Cloud beat consensus by 5% on revenue and by 14% on operating income. Advertising fell short: total ads of USD 82bn came in 1.8% below estimates, with Search 2.5% and YouTube 1.7% below. Excluding the equity loss, EPS of USD 2.67 sits 11% under consensus, and operating cash flow was 20% short.</a:t>
             </a:r>
             <a:endParaRPr lang="en-US" sz="870" dirty="0"/>
           </a:p>
@@ -2691,7 +2691,7 @@
                 <a:ea typeface="Nunito" pitchFamily="34" charset="-122"/>
                 <a:cs typeface="Nunito" pitchFamily="34" charset="-120"/>
               </a:rPr>
-              <a:t>The investment case remains intact and the risk/reward has improved with the fall. We underwrite revenue growth of around 20% into 2027, led by Cloud, and expect consensus EPS to come down as depreciation rises. The debate has moved from AI demand to the payback on capex, with a Cloud backlog of USD 561bn as support. Near USD 292, the stock trades 10% below its long-run multiple. The next test is the Q4 report in early February and the 2027 capex plan.</a:t>
+              <a:t>The investment case remains intact: good for AI growth, tough on near-term earnings. We underwrite revenue growth of around 20% into 2027, led by Cloud, whose USD 561bn backlog is just over 55% due within 24 months. Consensus EPS should come down as depreciation rises and capex grows again in 2027. Near USD 292, the stock trades 10% below its long-run multiple and the risk/reward has improved. The next test is the Q4 report in early February.</a:t>
             </a:r>
             <a:endParaRPr lang="en-US" sz="870" dirty="0"/>
           </a:p>
@@ -2818,7 +2818,7 @@
                 <a:ea typeface="Nunito" pitchFamily="34" charset="-122"/>
                 <a:cs typeface="Nunito" pitchFamily="34" charset="-120"/>
               </a:rPr>
-              <a:t>Google Cloud margin above 30% in Q4 despite third-party capacity costs; Search growth back to 15% or more; buybacks resuming in Q4; TPU contracts turning into the revenue management expects for 2027.</a:t>
+              <a:t>Ads in AI Mode closing the monetisation gap as they roll out abroad; Search growth holding in Q4 despite FX; Cloud margin above 30% through the third-party capacity ramp; buybacks resuming.</a:t>
             </a:r>
             <a:endParaRPr lang="en-US" sz="870" dirty="0"/>
           </a:p>
@@ -2899,7 +2899,7 @@
                 <a:ea typeface="Nunito" pitchFamily="34" charset="-122"/>
                 <a:cs typeface="Nunito" pitchFamily="34" charset="-120"/>
               </a:rPr>
-              <a:t>Free cash flow negative again in Q4 with no restart of buybacks; Search growth below 10% as retail media takes budget; a 2027 capex plan well above 2026 without a matching rise in the Cloud backlog.</a:t>
+              <a:t>Free cash flow negative again in Q4 without a fine payment; Search slowing further as AI Mode takes queries; 2027 capex rising faster than the USD 561bn Cloud backlog turns into revenue.</a:t>
             </a:r>
             <a:endParaRPr lang="en-US" sz="870" dirty="0"/>
           </a:p>
@@ -3159,7 +3159,7 @@
                 <a:ea typeface="Nunito" pitchFamily="34" charset="-122"/>
                 <a:cs typeface="Nunito" pitchFamily="34" charset="-120"/>
               </a:rPr>
-              <a:t>Results: Cloud carried, advertising slowed</a:t>
+              <a:t>Results: Search slowed on FX and AI Mode</a:t>
             </a:r>
             <a:endParaRPr lang="en-US" sz="1100" dirty="0"/>
           </a:p>
@@ -3174,7 +3174,7 @@
         <p:spPr>
           <a:xfrm>
             <a:off x="539496" y="1485900"/>
-            <a:ext cx="6483096" cy="802767"/>
+            <a:ext cx="6483096" cy="959663"/>
           </a:xfrm>
           <a:prstGeom prst="rect">
             <a:avLst/>
@@ -3201,7 +3201,7 @@
                 <a:ea typeface="Nunito" pitchFamily="34" charset="-122"/>
                 <a:cs typeface="Nunito" pitchFamily="34" charset="-120"/>
               </a:rPr>
-              <a:t>Revenue rose 25% to USD 127.6bn and operating income 30% to USD 40.6bn. Google Cloud did most of the work: revenue grew 103% to USD 30.7bn on demand for AI infrastructure, enterprise AI tools and the first TPU system sales, and operating income more than tripled to USD 11.1bn, a 36.2% margin. Google Services revenue of USD 96.3bn missed by 2.2% and its operating income of USD 39.2bn by 3.9%. Search grew 12% to USD 63.4bn, down from 17% in Q2; management cited currency and a Q2 lifted by the FIFA World Cup. YouTube ads grew 9% to USD 11.2bn. Net income fell 25% to USD 26.2bn.</a:t>
+              <a:t>Revenue rose 25% to USD 127.6bn and operating income 30% to USD 40.6bn. Google Cloud revenue grew 103% to USD 30.7bn and its operating income more than tripled to USD 11.1bn, a 36.2% margin. Search grew 12% to USD 63.3bn, down from 17% in Q2. Management named FX the single largest driver of that slowdown, followed by APAC retailers hit by the end of the EU de minimis exemption and World Cup budgets spent in June. It added that AI Mode, growing fast, monetises less. The FX comment covers the slowdown versus Q2 and leaves the miss versus consensus open. Management did not cite competition from OpenAI; we treat that as a separate risk.</a:t>
             </a:r>
             <a:endParaRPr lang="en-US" sz="870" dirty="0"/>
           </a:p>
@@ -3215,8 +3215,8 @@
         </p:nvSpPr>
         <p:spPr>
           <a:xfrm>
-            <a:off x="539496" y="2368220"/>
-            <a:ext cx="6483096" cy="802767"/>
+            <a:off x="539496" y="2525116"/>
+            <a:ext cx="6483096" cy="959663"/>
           </a:xfrm>
           <a:prstGeom prst="rect">
             <a:avLst/>
@@ -3243,7 +3243,7 @@
                 <a:ea typeface="Nunito" pitchFamily="34" charset="-122"/>
                 <a:cs typeface="Nunito" pitchFamily="34" charset="-120"/>
               </a:rPr>
-              <a:t>The miss and the pre-market fall of more than 10% on 29 October point the same way, though the move goes beyond the operating shortfall. Most of the EPS gap is non-operating: a USD 8.7bn loss on equity stakes, mainly SpaceX, cost USD 0.55 per share. The confirmed drivers sit elsewhere. The operating margin fell to 31.8% from 34.0% in Q2 as depreciation rose, free cash flow was -USD 9.1bn against -USD 2.7bn expected, and no shares were bought back. The stock had already lost 8% since 13 October. We think investors now question the payback on capex, and the buyback halt removes a support.</a:t>
+              <a:t>The miss and the pre-market fall of more than 10% on 29 October point the same way, and the size of the move tracks the margin. Confirmed drivers: higher depreciation and a USD 7.7bn Alphabet-level operating loss, mainly from shared AI research. The 36.2% Cloud margin excludes those shared costs, so we judge the offset on group profit and cash. Free cash flow of -USD 9.1bn reflected capex, TPU inventory and a USD 5.2bn payment for a 2018 EC fine; without the fine it would be about -USD 3.9bn, our calculation. No shares were bought back. We think investors now question the payback on capex.</a:t>
             </a:r>
             <a:endParaRPr lang="en-US" sz="870" dirty="0"/>
           </a:p>
@@ -3257,7 +3257,7 @@
         </p:nvSpPr>
         <p:spPr>
           <a:xfrm>
-            <a:off x="539496" y="3287116"/>
+            <a:off x="539496" y="3600907"/>
             <a:ext cx="6483096" cy="219456"/>
           </a:xfrm>
           <a:prstGeom prst="rect">
@@ -3282,7 +3282,7 @@
                 <a:ea typeface="Nunito" pitchFamily="34" charset="-122"/>
                 <a:cs typeface="Nunito" pitchFamily="34" charset="-120"/>
               </a:rPr>
-              <a:t>Outlook: heavier spending, TPU revenue in 2027</a:t>
+              <a:t>Outlook: capex unchanged, costs rise in Q4</a:t>
             </a:r>
             <a:endParaRPr lang="en-US" sz="1100" dirty="0"/>
           </a:p>
@@ -3296,8 +3296,8 @@
         </p:nvSpPr>
         <p:spPr>
           <a:xfrm>
-            <a:off x="539496" y="3534004"/>
-            <a:ext cx="6483096" cy="959663"/>
+            <a:off x="539496" y="3847795"/>
+            <a:ext cx="6483096" cy="802767"/>
           </a:xfrm>
           <a:prstGeom prst="rect">
             <a:avLst/>
@@ -3324,7 +3324,7 @@
                 <a:ea typeface="Nunito" pitchFamily="34" charset="-122"/>
                 <a:cs typeface="Nunito" pitchFamily="34" charset="-120"/>
               </a:rPr>
-              <a:t>Management flagged near-term pressure on Cloud margins as higher-cost third-party capacity fills gaps in its own supply, with the cost rising in Q4. Capex reached USD 51.4bn in Q3, up 114%, taking the nine-month total to about USD 132bn. The full-year plan of USD 195bn to 205bn, set in July, implies USD 63bn to 73bn in Q4. The Cloud backlog stands at USD 561bn, and management expects the vast majority of TPU system revenue in 2027. Usage keeps climbing: first-party models process 32 billion tokens per minute and the Gemini app has one billion users. Cash and securities of USD 265.1bn cover long-term debt of USD 125.1bn twice.</a:t>
+              <a:t>Management kept the 2026 capex range of USD 195bn to 205bn, which implies USD 63bn to 73bn in Q4 after USD 51.4bn in Q3, and expects capex to rise significantly in 2027. Third-party compute came online at the very end of Q3 and ramps in Q4, and the CFO expects near-term margin headwinds from it. FX should weigh more in Q4, mainly on Search and YouTube. To lift Search monetisation, Google is scaling ads in AI Mode and AI Overviews, taking them abroad for the first time and adding multi-turn ads in the US. TPU system revenue should ramp meaningfully in 2027.</a:t>
             </a:r>
             <a:endParaRPr lang="en-US" sz="870" dirty="0"/>
           </a:p>
@@ -3338,7 +3338,7 @@
         </p:nvSpPr>
         <p:spPr>
           <a:xfrm>
-            <a:off x="539496" y="4609795"/>
+            <a:off x="539496" y="4766691"/>
             <a:ext cx="6483096" cy="219456"/>
           </a:xfrm>
           <a:prstGeom prst="rect">
@@ -3377,7 +3377,7 @@
         </p:nvSpPr>
         <p:spPr>
           <a:xfrm>
-            <a:off x="539496" y="4856683"/>
+            <a:off x="539496" y="5013579"/>
             <a:ext cx="6483096" cy="173736"/>
           </a:xfrm>
           <a:prstGeom prst="rect">
@@ -3430,7 +3430,7 @@
         </p:nvSpPr>
         <p:spPr>
           <a:xfrm>
-            <a:off x="539496" y="5030419"/>
+            <a:off x="539496" y="5187315"/>
             <a:ext cx="6483096" cy="115570"/>
           </a:xfrm>
           <a:prstGeom prst="rect">
@@ -3480,7 +3480,7 @@
         </p:blipFill>
         <p:spPr>
           <a:xfrm>
-            <a:off x="928482" y="5191709"/>
+            <a:off x="928482" y="5348605"/>
             <a:ext cx="5705124" cy="3413946"/>
           </a:xfrm>
           <a:prstGeom prst="rect">
@@ -3496,7 +3496,7 @@
         </p:nvSpPr>
         <p:spPr>
           <a:xfrm>
-            <a:off x="539496" y="8660520"/>
+            <a:off x="539496" y="8817415"/>
             <a:ext cx="6483096" cy="802767"/>
           </a:xfrm>
           <a:prstGeom prst="rect">
@@ -3735,7 +3735,7 @@
                 <a:ea typeface="Nunito" pitchFamily="34" charset="-122"/>
                 <a:cs typeface="Nunito" pitchFamily="34" charset="-120"/>
               </a:rPr>
-              <a:t> Source: Syz Research, Bloomberg, company filings, Alphabet Q3 2026 results of 28 October 2026, analyst research notes of 29 October 2026</a:t>
+              <a:t> Source: Syz Research, Bloomberg, company filings, Alphabet Q3 2026 earnings call of 28 October 2026, press coverage and analyst research notes of 29 October 2026</a:t>
             </a:r>
             <a:endParaRPr lang="en-US" sz="700" dirty="0"/>
           </a:p>

</xml_diff>

<commit_message>
Alphabet Q3 2026: AI Mode quote, Search, cash flow and Cloud offset qualified
Schindler quote on AI Mode monetisation; Search slowdown attributed as
management did (FX first vs. Q2), with no evidence of OpenAI taking ad
budgets; EC fine separated from ongoing AI spending in free cash flow;
Cloud offset assessed on profit vs. capex and cash.

Co-Authored-By: Claude Opus 5.5 <noreply@anthropic.com>
Claude-Session: https://claude.ai/code/session_0194roGPqBhaRAXzfYFupgCj
</commit_message>
<xml_diff>
--- a/deliverables/GOOGL_Q3_2026/Earnings_Update_GOOGL_Q32026.pptx
+++ b/deliverables/GOOGL_Q3_2026/Earnings_Update_GOOGL_Q32026.pptx
@@ -1360,7 +1360,7 @@
                 <a:ea typeface="Nunito" pitchFamily="34" charset="-122"/>
                 <a:cs typeface="Nunito" pitchFamily="34" charset="-120"/>
               </a:rPr>
-              <a:t>“The significant increase in our investment in technical infrastructure will continue to weigh on the P&amp;L in the form of higher depreciation expenses and related data center operations costs, such as energy.”</a:t>
+              <a:t>“The strong growth in AI Mode queries had an impact because of the lower monetization we were seeing in AI Mode. To be clear, we feel very good about our trajectory here.”</a:t>
             </a:r>
             <a:endParaRPr lang="en-US" sz="870" dirty="0"/>
           </a:p>
@@ -1399,7 +1399,7 @@
                 <a:ea typeface="Nunito" pitchFamily="34" charset="-122"/>
                 <a:cs typeface="Nunito" pitchFamily="34" charset="-120"/>
               </a:rPr>
-              <a:t>Anat Ashkenazi, CFO, Alphabet Q3 2026 earnings call, 28 October 2026</a:t>
+              <a:t>Philipp Schindler, Chief Business Officer, Google, Alphabet Q3 2026 earnings call, 28 October 2026</a:t>
             </a:r>
             <a:endParaRPr lang="en-US" sz="700" dirty="0"/>
           </a:p>
@@ -2610,7 +2610,7 @@
                 <a:ea typeface="Nunito" pitchFamily="34" charset="-122"/>
                 <a:cs typeface="Nunito" pitchFamily="34" charset="-120"/>
               </a:rPr>
-              <a:t>Google Cloud beat consensus by 5% on revenue and by 14% on operating income. Advertising fell short: total ads of USD 82bn came in 1.8% below estimates, with Search 2.5% and YouTube 1.7% below. Excluding the equity loss, EPS of USD 2.67 sits 11% under consensus, and operating cash flow was 20% short.</a:t>
+              <a:t>Google Cloud beat consensus by 5% on revenue and by 14% on operating income. Advertising fell short: total ads of USD 82bn were 1.8% below estimates. Excluding the equity loss, EPS of USD 2.67 sits 11% under consensus. Negative free cash flow of USD 9.1bn includes a USD 5.2bn EC fine; without it, the outflow is about USD 3.9bn.</a:t>
             </a:r>
             <a:endParaRPr lang="en-US" sz="870" dirty="0"/>
           </a:p>
@@ -2664,7 +2664,7 @@
         <p:spPr>
           <a:xfrm>
             <a:off x="658368" y="8036357"/>
-            <a:ext cx="6245352" cy="645871"/>
+            <a:ext cx="6245352" cy="802767"/>
           </a:xfrm>
           <a:prstGeom prst="rect">
             <a:avLst/>
@@ -2691,7 +2691,7 @@
                 <a:ea typeface="Nunito" pitchFamily="34" charset="-122"/>
                 <a:cs typeface="Nunito" pitchFamily="34" charset="-120"/>
               </a:rPr>
-              <a:t>The investment case remains intact: good for AI growth, tough on near-term earnings. We underwrite revenue growth of around 20% into 2027, led by Cloud, whose USD 561bn backlog is just over 55% due within 24 months. Consensus EPS should come down as depreciation rises and capex grows again in 2027. Near USD 292, the stock trades 10% below its long-run multiple and the risk/reward has improved. The next test is the Q4 report in early February.</a:t>
+              <a:t>The investment case remains intact: good for AI growth, tough on near-term earnings. We underwrite revenue growth of around 20% into 2027. Cloud offsets part of the Search pressure in profit, with just over 55% of its USD 561bn backlog due within 24 months; the cash payback comes later. Consensus EPS should come down as depreciation rises and capex grows again in 2027. Near USD 292, the stock trades 10% below its long-run multiple and the risk/reward has improved. The next test is the Q4 report in February.</a:t>
             </a:r>
             <a:endParaRPr lang="en-US" sz="870" dirty="0"/>
           </a:p>
@@ -2705,7 +2705,7 @@
         </p:nvSpPr>
         <p:spPr>
           <a:xfrm>
-            <a:off x="658368" y="8761781"/>
+            <a:off x="658368" y="8918677"/>
             <a:ext cx="6245352" cy="0"/>
           </a:xfrm>
           <a:prstGeom prst="line">
@@ -2728,7 +2728,7 @@
         </p:nvSpPr>
         <p:spPr>
           <a:xfrm>
-            <a:off x="3781044" y="8871509"/>
+            <a:off x="3781044" y="9028405"/>
             <a:ext cx="0" cy="828751"/>
           </a:xfrm>
           <a:prstGeom prst="line">
@@ -2751,7 +2751,7 @@
         </p:nvSpPr>
         <p:spPr>
           <a:xfrm>
-            <a:off x="658368" y="8871509"/>
+            <a:off x="658368" y="9028405"/>
             <a:ext cx="2939796" cy="155448"/>
           </a:xfrm>
           <a:prstGeom prst="rect">
@@ -2790,7 +2790,7 @@
         </p:nvSpPr>
         <p:spPr>
           <a:xfrm>
-            <a:off x="658368" y="9063533"/>
+            <a:off x="658368" y="9220429"/>
             <a:ext cx="2939796" cy="627583"/>
           </a:xfrm>
           <a:prstGeom prst="rect">
@@ -2832,7 +2832,7 @@
         </p:nvSpPr>
         <p:spPr>
           <a:xfrm>
-            <a:off x="3963924" y="8871509"/>
+            <a:off x="3963924" y="9028405"/>
             <a:ext cx="2939796" cy="155448"/>
           </a:xfrm>
           <a:prstGeom prst="rect">
@@ -2871,7 +2871,7 @@
         </p:nvSpPr>
         <p:spPr>
           <a:xfrm>
-            <a:off x="3963924" y="9063533"/>
+            <a:off x="3963924" y="9220429"/>
             <a:ext cx="2939796" cy="627583"/>
           </a:xfrm>
           <a:prstGeom prst="rect">
@@ -2914,11 +2914,11 @@
         <p:spPr>
           <a:xfrm>
             <a:off x="539496" y="7725461"/>
-            <a:ext cx="6483096" cy="2038807"/>
+            <a:ext cx="6483096" cy="2195703"/>
           </a:xfrm>
           <a:prstGeom prst="roundRect">
             <a:avLst>
-              <a:gd name="adj" fmla="val 4485"/>
+              <a:gd name="adj" fmla="val 4164"/>
             </a:avLst>
           </a:prstGeom>
           <a:ln w="16510">
@@ -3201,7 +3201,7 @@
                 <a:ea typeface="Nunito" pitchFamily="34" charset="-122"/>
                 <a:cs typeface="Nunito" pitchFamily="34" charset="-120"/>
               </a:rPr>
-              <a:t>Revenue rose 25% to USD 127.6bn and operating income 30% to USD 40.6bn. Google Cloud revenue grew 103% to USD 30.7bn and its operating income more than tripled to USD 11.1bn, a 36.2% margin. Search grew 12% to USD 63.3bn, down from 17% in Q2. Management named FX the single largest driver of that slowdown, followed by APAC retailers hit by the end of the EU de minimis exemption and World Cup budgets spent in June. It added that AI Mode, growing fast, monetises less. The FX comment covers the slowdown versus Q2 and leaves the miss versus consensus open. Management did not cite competition from OpenAI; we treat that as a separate risk.</a:t>
+              <a:t>Revenue rose 25% to USD 127.6bn and operating income 30% to USD 40.6bn. Search grew 12% to USD 63.3bn, down from 17% in Q2. Philipp Schindler named FX the single largest driver of that slowdown, then APAC retailers hit by the end of the EU de minimis exemption, World Cup budgets spent in June and lower monetisation in AI Mode. The FX comment covers the slowdown versus Q2 and leaves the miss versus consensus open. The numbers show monetisation pressure as queries move to AI Mode, where Google is now scaling ads, abroad for the first time. Management did not cite OpenAI, and nothing in the results shows it taking material ad budgets.</a:t>
             </a:r>
             <a:endParaRPr lang="en-US" sz="870" dirty="0"/>
           </a:p>
@@ -3216,7 +3216,7 @@
         <p:spPr>
           <a:xfrm>
             <a:off x="539496" y="2525116"/>
-            <a:ext cx="6483096" cy="959663"/>
+            <a:ext cx="6483096" cy="802767"/>
           </a:xfrm>
           <a:prstGeom prst="rect">
             <a:avLst/>
@@ -3243,7 +3243,7 @@
                 <a:ea typeface="Nunito" pitchFamily="34" charset="-122"/>
                 <a:cs typeface="Nunito" pitchFamily="34" charset="-120"/>
               </a:rPr>
-              <a:t>The miss and the pre-market fall of more than 10% on 29 October point the same way, and the size of the move tracks the margin. Confirmed drivers: higher depreciation and a USD 7.7bn Alphabet-level operating loss, mainly from shared AI research. The 36.2% Cloud margin excludes those shared costs, so we judge the offset on group profit and cash. Free cash flow of -USD 9.1bn reflected capex, TPU inventory and a USD 5.2bn payment for a 2018 EC fine; without the fine it would be about -USD 3.9bn, our calculation. No shares were bought back. We think investors now question the payback on capex.</a:t>
+              <a:t>The miss and the pre-market fall of more than 10% on 29 October point the same way, and the size of the move tracks the margin, hit by depreciation and a USD 7.7bn Alphabet-level loss, mainly from shared AI research. Negative free cash flow of USD 9.1bn needs a split. The USD 5.2bn payment for a 2018 EC fine is exceptional; without it, the outflow would be about USD 3.9bn, our calculation. The rest reflects ongoing AI investment and TPU inventory and remains a heavy drain. No shares were bought back. We think investors now question the payback on capex.</a:t>
             </a:r>
             <a:endParaRPr lang="en-US" sz="870" dirty="0"/>
           </a:p>
@@ -3257,7 +3257,7 @@
         </p:nvSpPr>
         <p:spPr>
           <a:xfrm>
-            <a:off x="539496" y="3600907"/>
+            <a:off x="539496" y="3444011"/>
             <a:ext cx="6483096" cy="219456"/>
           </a:xfrm>
           <a:prstGeom prst="rect">
@@ -3282,7 +3282,7 @@
                 <a:ea typeface="Nunito" pitchFamily="34" charset="-122"/>
                 <a:cs typeface="Nunito" pitchFamily="34" charset="-120"/>
               </a:rPr>
-              <a:t>Outlook: capex unchanged, costs rise in Q4</a:t>
+              <a:t>Outlook: Cloud covers profit, cash lags</a:t>
             </a:r>
             <a:endParaRPr lang="en-US" sz="1100" dirty="0"/>
           </a:p>
@@ -3296,7 +3296,7 @@
         </p:nvSpPr>
         <p:spPr>
           <a:xfrm>
-            <a:off x="539496" y="3847795"/>
+            <a:off x="539496" y="3690899"/>
             <a:ext cx="6483096" cy="802767"/>
           </a:xfrm>
           <a:prstGeom prst="rect">
@@ -3324,7 +3324,7 @@
                 <a:ea typeface="Nunito" pitchFamily="34" charset="-122"/>
                 <a:cs typeface="Nunito" pitchFamily="34" charset="-120"/>
               </a:rPr>
-              <a:t>Management kept the 2026 capex range of USD 195bn to 205bn, which implies USD 63bn to 73bn in Q4 after USD 51.4bn in Q3, and expects capex to rise significantly in 2027. Third-party compute came online at the very end of Q3 and ramps in Q4, and the CFO expects near-term margin headwinds from it. FX should weigh more in Q4, mainly on Search and YouTube. To lift Search monetisation, Google is scaling ads in AI Mode and AI Overviews, taking them abroad for the first time and adding multi-turn ads in the US. TPU system revenue should ramp meaningfully in 2027.</a:t>
+              <a:t>Google Cloud revenue grew 103% to USD 30.7bn and operating income more than tripled to USD 11.1bn, a 36.2% margin. Cloud profit rose by about USD 7.5bn year on year, our estimate, against a USD 27bn rise in quarterly capex. The segment margin leaves out the shared AI research costs, and the CFO expects “margin headwinds in the near term” as Google uses third-party compute in Q4. Cloud can cover weaker Search monetisation at the profit line; cash returns lag until TPU system revenue ramps in 2027. Management kept the 2026 capex range of USD 195bn to 205bn and expects a steep rise in 2027.</a:t>
             </a:r>
             <a:endParaRPr lang="en-US" sz="870" dirty="0"/>
           </a:p>
@@ -3338,7 +3338,7 @@
         </p:nvSpPr>
         <p:spPr>
           <a:xfrm>
-            <a:off x="539496" y="4766691"/>
+            <a:off x="539496" y="4609795"/>
             <a:ext cx="6483096" cy="219456"/>
           </a:xfrm>
           <a:prstGeom prst="rect">
@@ -3377,7 +3377,7 @@
         </p:nvSpPr>
         <p:spPr>
           <a:xfrm>
-            <a:off x="539496" y="5013579"/>
+            <a:off x="539496" y="4856683"/>
             <a:ext cx="6483096" cy="173736"/>
           </a:xfrm>
           <a:prstGeom prst="rect">
@@ -3430,7 +3430,7 @@
         </p:nvSpPr>
         <p:spPr>
           <a:xfrm>
-            <a:off x="539496" y="5187315"/>
+            <a:off x="539496" y="5030419"/>
             <a:ext cx="6483096" cy="115570"/>
           </a:xfrm>
           <a:prstGeom prst="rect">
@@ -3480,7 +3480,7 @@
         </p:blipFill>
         <p:spPr>
           <a:xfrm>
-            <a:off x="928482" y="5348605"/>
+            <a:off x="928482" y="5191709"/>
             <a:ext cx="5705124" cy="3413946"/>
           </a:xfrm>
           <a:prstGeom prst="rect">
@@ -3496,7 +3496,7 @@
         </p:nvSpPr>
         <p:spPr>
           <a:xfrm>
-            <a:off x="539496" y="8817415"/>
+            <a:off x="539496" y="8660520"/>
             <a:ext cx="6483096" cy="802767"/>
           </a:xfrm>
           <a:prstGeom prst="rect">

</xml_diff>